<commit_message>
sandbox: fix executive summary template alignment
</commit_message>
<xml_diff>
--- a/sandbox/qubit_external_coupling_analysis/outputs/slides/personal_slide_template/output/qeca_personal_slide_template.pptx
+++ b/sandbox/qubit_external_coupling_analysis/outputs/slides/personal_slide_template/output/qeca_personal_slide_template.pptx
@@ -6963,7 +6963,7 @@
         </p:nvSpPr>
         <p:spPr>
           <a:xfrm>
-            <a:off x="969264" y="1627632"/>
+            <a:off x="749808" y="1627632"/>
             <a:ext cx="2487168" cy="164592"/>
           </a:xfrm>
           <a:prstGeom prst="rect">
@@ -7095,7 +7095,7 @@
         </p:nvSpPr>
         <p:spPr>
           <a:xfrm>
-            <a:off x="3803904" y="1627632"/>
+            <a:off x="3584448" y="1627632"/>
             <a:ext cx="2487168" cy="164592"/>
           </a:xfrm>
           <a:prstGeom prst="rect">
@@ -7227,7 +7227,7 @@
         </p:nvSpPr>
         <p:spPr>
           <a:xfrm>
-            <a:off x="6638544" y="1627632"/>
+            <a:off x="6419088" y="1627632"/>
             <a:ext cx="2487168" cy="164592"/>
           </a:xfrm>
           <a:prstGeom prst="rect">
@@ -7359,7 +7359,7 @@
         </p:nvSpPr>
         <p:spPr>
           <a:xfrm>
-            <a:off x="9473184" y="1627632"/>
+            <a:off x="9253728" y="1627632"/>
             <a:ext cx="2487168" cy="164592"/>
           </a:xfrm>
           <a:prstGeom prst="rect">

</xml_diff>